<commit_message>
Deck slide 10: replace "Why we win" with a humble, evidence-led summary
"Why ParkPulse wins" presumes the verdict and reads as overconfident to a BTP/gov
panel. Reframed to "ParkPulse, in summary" — the four judging criteria each backed
by a concrete fact (confident because substantiated, not boastful) + a by-the-numbers
strip + a single QR. Title/Description/Links/Run/Source stay in the form fields, not the slide.

Co-Authored-By: Claude Opus 4.8 <noreply@anthropic.com>
Claude-Session: https://claude.ai/code/session_01Xr9DYnKWkghcBQLrU88Njx
</commit_message>
<xml_diff>
--- a/pitch/ParkPulse_Submission_Deck.pptx
+++ b/pitch/ParkPulse_Submission_Deck.pptx
@@ -3529,7 +3529,7 @@
                 </a:solidFill>
                 <a:latin typeface="Segoe UI"/>
               </a:rPr>
-              <a:t>Slide 10 · Supporting Links &amp; Documentation</a:t>
+              <a:t>Slide 10 · ParkPulse, in summary</a:t>
             </a:r>
           </a:p>
         </p:txBody>
@@ -3568,7 +3568,7 @@
                 </a:solidFill>
                 <a:latin typeface="Segoe UI"/>
               </a:rPr>
-              <a:t>Everything to verify it runs</a:t>
+              <a:t>Feasible. Relevant. Innovative. Proven — the evidence.</a:t>
             </a:r>
           </a:p>
         </p:txBody>
@@ -3607,7 +3607,7 @@
                 </a:solidFill>
                 <a:latin typeface="Segoe UI"/>
               </a:rPr>
-              <a:t>•  Live web app (Next.js on Vercel): [Vercel URL]</a:t>
+              <a:t>•  Feasible — runs today on data BTP already collects; no new sensors or hardware.</a:t>
             </a:r>
           </a:p>
           <a:p>
@@ -3623,7 +3623,7 @@
                 </a:solidFill>
                 <a:latin typeface="Segoe UI"/>
               </a:rPr>
-              <a:t>•  Backend API (FastAPI on Render): [Render URL]/health</a:t>
+              <a:t>•  Relevant — built on their own 298,445 records, read honestly (enforcement data, not demand; evening gap named).</a:t>
             </a:r>
           </a:p>
           <a:p>
@@ -3639,7 +3639,7 @@
                 </a:solidFill>
                 <a:latin typeface="Segoe UI"/>
               </a:rPr>
-              <a:t>•  Code repository: [GitHub repo URL]   ·   Demo video: [link — ~3–5 min walkthrough]</a:t>
+              <a:t>•  Innovative — a closed decision loop, explainable both ways, with an agentic voice co-pilot.</a:t>
             </a:r>
           </a:p>
           <a:p>
@@ -3655,7 +3655,7 @@
                 </a:solidFill>
                 <a:latin typeface="Segoe UI"/>
               </a:rPr>
-              <a:t>•  Run locally: python fullstack/backend/main.py  ·  cd fullstack/frontend &amp;&amp; npm install &amp;&amp; npm run dev</a:t>
+              <a:t>•  Proven — 38% of real violations captured on 31 days the model never saw; held-out r = 0.70.</a:t>
             </a:r>
           </a:p>
           <a:p>
@@ -3671,7 +3671,46 @@
                 </a:solidFill>
                 <a:latin typeface="Segoe UI"/>
               </a:rPr>
-              <a:t>•  Team: TeamX — Shubham, Satyam, Palash.  ParkPulse: turning what already happened into where to stand tomorrow.</a:t>
+              <a:t>•  By the numbers: 298,445 records · r = 0.70 · 38% vs 1.3% · 802 zones · English / Hindi / Kannada · runs on a laptop.</a:t>
+            </a:r>
+          </a:p>
+        </p:txBody>
+      </p:sp>
+      <p:sp>
+        <p:nvSpPr>
+          <p:cNvPr id="7" name="TextBox 6"/>
+          <p:cNvSpPr txBox="1"/>
+          <p:nvPr/>
+        </p:nvSpPr>
+        <p:spPr>
+          <a:xfrm>
+            <a:off x="822960" y="6172200"/>
+            <a:ext cx="10515600" cy="457200"/>
+          </a:xfrm>
+          <a:prstGeom prst="rect">
+            <a:avLst/>
+          </a:prstGeom>
+          <a:noFill/>
+        </p:spPr>
+        <p:txBody>
+          <a:bodyPr wrap="square" anchor="t">
+            <a:spAutoFit/>
+          </a:bodyPr>
+          <a:lstStyle/>
+          <a:p>
+            <a:pPr algn="l">
+              <a:spcAft>
+                <a:spcPts val="600"/>
+              </a:spcAft>
+            </a:pPr>
+            <a:r>
+              <a:rPr sz="1300" b="0">
+                <a:solidFill>
+                  <a:srgbClr val="9AA3B2"/>
+                </a:solidFill>
+                <a:latin typeface="Segoe UI"/>
+              </a:rPr>
+              <a:t>ParkPulse — turning what already happened into where to stand tomorrow.  ·  Team TeamX (Shubham, Satyam, Palash)  ·  one QR → live app</a:t>
             </a:r>
           </a:p>
         </p:txBody>

</xml_diff>